<commit_message>
Unit 4 deck: new 5.3 slide and notes (boxes 4A-4F); Unit 5 deck: two highest-risk dimensions (boxes 5A-5C); reader folders; handover
Co-Authored-By: Claude Opus 5.5 <noreply@anthropic.com>

Claude-Session: https://claude.ai/code/session_01XPPoLFsFZBzmCgWNMADhB8
</commit_message>
<xml_diff>
--- a/Unit decks/Unit 04 - Direction Integrity (ABCV-MBT).pptx
+++ b/Unit decks/Unit 04 - Direction Integrity (ABCV-MBT).pptx
@@ -36,6 +36,7 @@
     <p:sldId id="283" r:id="rId24"/>
     <p:sldId id="284" r:id="rId25"/>
     <p:sldId id="286" r:id="rId26"/>
+    <p:sldId id="294" r:id="rId36"/>
     <p:sldId id="290" r:id="rId30"/>
   </p:sldIdLst>
   <p:sldSz cx="12192000" cy="6858000"/>
@@ -2944,106 +2945,112 @@
           <a:lstStyle/>
           <a:p>
             <a:r>
-              <a:rPr lang="en-GB" b="1" dirty="0"/>
+              <a:rPr lang="en-GB"/>
               <a:t>SECTION 5 · APPLICATION — IN PRACTICE</a:t>
             </a:r>
           </a:p>
           <a:p>
-            <a:endParaRPr lang="en-GB" dirty="0"/>
-          </a:p>
-          <a:p>
-            <a:r>
-              <a:rPr lang="en-GB" b="1" dirty="0"/>
+            <a:endParaRPr lang="en-GB"/>
+          </a:p>
+          <a:p>
+            <a:r>
+              <a:rPr lang="en-GB"/>
               <a:t>HOW THIS SECTION RUNS:</a:t>
             </a:r>
           </a:p>
           <a:p>
             <a:r>
-              <a:rPr lang="en-GB" dirty="0"/>
+              <a:rPr lang="en-GB"/>
               <a:t>1. 5.1: the worked example. One Key Result of the client services company from Unit 3, taken through four steps, on six slides.</a:t>
             </a:r>
           </a:p>
           <a:p>
             <a:r>
-              <a:rPr lang="en-GB" dirty="0"/>
+              <a:rPr lang="en-GB"/>
               <a:t>2. 5.2: the briefing for the Capstone work. Each group takes its own Unit 3 Key Results through the same four steps.</a:t>
             </a:r>
           </a:p>
           <a:p>
-            <a:endParaRPr lang="en-GB" dirty="0"/>
-          </a:p>
-          <a:p>
-            <a:r>
-              <a:rPr lang="en-GB" b="1" dirty="0"/>
+            <a:r>
+              <a:rPr lang="en-GB"/>
+              <a:t>3. 5.3: verification ownership and the executive blind spot. The group assigns each critical condition to an executive and names the checkpoint its team is most likely to overlook.</a:t>
+            </a:r>
+          </a:p>
+          <a:p>
+            <a:endParaRPr lang="en-GB"/>
+          </a:p>
+          <a:p>
+            <a:r>
+              <a:rPr lang="en-GB"/>
               <a:t>SECTION LEARNING OUTCOMES:</a:t>
             </a:r>
           </a:p>
           <a:p>
             <a:r>
-              <a:rPr lang="en-GB" dirty="0"/>
+              <a:rPr lang="en-GB"/>
               <a:t>1. Validate the critical assumptions, dependencies and uncertainties behind strategic objectives.</a:t>
             </a:r>
           </a:p>
           <a:p>
             <a:r>
-              <a:rPr lang="en-GB" dirty="0"/>
+              <a:rPr lang="en-GB"/>
               <a:t>2. Assign and coordinate executive accountability for validating strategic conditions.</a:t>
             </a:r>
           </a:p>
           <a:p>
-            <a:endParaRPr lang="en-GB" dirty="0"/>
-          </a:p>
-          <a:p>
-            <a:r>
-              <a:rPr lang="en-GB" b="1" dirty="0"/>
+            <a:endParaRPr lang="en-GB"/>
+          </a:p>
+          <a:p>
+            <a:r>
+              <a:rPr lang="en-GB"/>
               <a:t>HOW TO OPEN THE SECTION:</a:t>
             </a:r>
           </a:p>
           <a:p>
-            <a:endParaRPr lang="en-GB" dirty="0"/>
-          </a:p>
-          <a:p>
-            <a:r>
-              <a:rPr lang="en-GB" b="1" dirty="0"/>
+            <a:endParaRPr lang="en-GB"/>
+          </a:p>
+          <a:p>
+            <a:r>
+              <a:rPr lang="en-GB"/>
               <a:t>1. Say what the section does.</a:t>
             </a:r>
           </a:p>
           <a:p>
             <a:r>
-              <a:rPr lang="en-GB" dirty="0"/>
+              <a:rPr lang="en-GB"/>
               <a:t>Say: "This is where the checkpoints are applied to your own direction.</a:t>
             </a:r>
           </a:p>
           <a:p>
             <a:r>
-              <a:rPr lang="en-GB" dirty="0"/>
+              <a:rPr lang="en-GB"/>
               <a:t>Your group brings in the Key Results it confirmed in Unit 3 and takes each one through four steps.</a:t>
             </a:r>
           </a:p>
           <a:p>
             <a:r>
-              <a:rPr lang="en-GB" dirty="0"/>
+              <a:rPr lang="en-GB"/>
               <a:t>At each step it names the condition that must remain true."</a:t>
             </a:r>
           </a:p>
           <a:p>
             <a:r>
-              <a:rPr lang="en-GB" dirty="0"/>
+              <a:rPr lang="en-GB"/>
               <a:t>This is Capstone work: the confirmed outputs feed each team’s Capstone Blueprint.</a:t>
             </a:r>
           </a:p>
           <a:p>
-            <a:endParaRPr lang="en-GB" dirty="0"/>
-          </a:p>
-          <a:p>
-            <a:r>
-              <a:rPr lang="en-GB" b="1" dirty="0"/>
+            <a:endParaRPr lang="en-GB"/>
+          </a:p>
+          <a:p>
+            <a:r>
+              <a:rPr lang="en-GB"/>
               <a:t>2. Say the order.</a:t>
             </a:r>
           </a:p>
           <a:p>
             <a:r>
-              <a:rPr lang="en-GB" dirty="0"/>
+              <a:rPr lang="en-GB"/>
               <a:t>Say: "We first walk one worked example in full. Your exercise then follows the worked example step for step."</a:t>
             </a:r>
           </a:p>
@@ -4423,303 +4430,271 @@
           <a:lstStyle/>
           <a:p>
             <a:r>
-              <a:rPr lang="en-GB" b="1" dirty="0"/>
+              <a:rPr lang="en-GB"/>
               <a:t>5.2 — STRESS-TESTING YOUR KEY RESULTS · THE FOUR STEPS (CAPSTONE WORK)</a:t>
             </a:r>
           </a:p>
           <a:p>
-            <a:endParaRPr lang="en-GB" dirty="0"/>
-          </a:p>
-          <a:p>
-            <a:r>
-              <a:rPr lang="en-GB" b="1" dirty="0"/>
+            <a:endParaRPr lang="en-GB"/>
+          </a:p>
+          <a:p>
+            <a:r>
+              <a:rPr lang="en-GB"/>
               <a:t>HOW TO TEACH IT:</a:t>
             </a:r>
           </a:p>
           <a:p>
-            <a:endParaRPr lang="en-GB" b="1" dirty="0"/>
-          </a:p>
-          <a:p>
-            <a:r>
-              <a:rPr lang="en-GB" b="1" dirty="0"/>
+            <a:endParaRPr lang="en-GB"/>
+          </a:p>
+          <a:p>
+            <a:r>
+              <a:rPr lang="en-GB"/>
               <a:t>Explain how the group works, using the four lines on the slide.</a:t>
             </a:r>
           </a:p>
           <a:p>
             <a:r>
-              <a:rPr lang="en-GB" dirty="0"/>
+              <a:rPr lang="en-GB"/>
               <a:t>Say: "Your group agrees each entry.</a:t>
             </a:r>
           </a:p>
           <a:p>
             <a:r>
-              <a:rPr lang="en-GB" dirty="0"/>
+              <a:rPr lang="en-GB"/>
               <a:t>The group chooses its scribe, who types the agreed wording.</a:t>
             </a:r>
           </a:p>
           <a:p>
             <a:r>
-              <a:rPr lang="en-GB" dirty="0"/>
+              <a:rPr lang="en-GB"/>
               <a:t>The entries appear on every member’s page, and each member then selects Agree."</a:t>
             </a:r>
           </a:p>
           <a:p>
-            <a:endParaRPr lang="en-GB" dirty="0"/>
-          </a:p>
-          <a:p>
-            <a:r>
-              <a:rPr lang="en-GB" b="1" dirty="0"/>
+            <a:endParaRPr lang="en-GB"/>
+          </a:p>
+          <a:p>
+            <a:r>
+              <a:rPr lang="en-GB"/>
               <a:t>Say what the group works on.</a:t>
             </a:r>
           </a:p>
           <a:p>
             <a:r>
-              <a:rPr lang="en-GB" dirty="0"/>
+              <a:rPr lang="en-GB"/>
               <a:t>Say: "Your group does for its own Key Results what the worked example did.</a:t>
             </a:r>
           </a:p>
           <a:p>
             <a:r>
-              <a:rPr lang="en-GB" dirty="0"/>
+              <a:rPr lang="en-GB"/>
               <a:t>Your confirmed Key Results from Unit 3 are already listed on your page.</a:t>
             </a:r>
           </a:p>
           <a:p>
             <a:r>
-              <a:rPr lang="en-GB" dirty="0"/>
+              <a:rPr lang="en-GB"/>
               <a:t>No new objective or measure is added."</a:t>
             </a:r>
           </a:p>
           <a:p>
-            <a:endParaRPr lang="en-GB" dirty="0"/>
-          </a:p>
-          <a:p>
-            <a:r>
-              <a:rPr lang="en-GB" b="1" dirty="0"/>
-              <a:t>Say when the work is confirmed.</a:t>
-            </a:r>
-          </a:p>
-          <a:p>
-            <a:r>
-              <a:rPr lang="en-GB" dirty="0"/>
-              <a:t>Say: "When every Key Result has been taken through the four steps, each of you confirms the record."</a:t>
-            </a:r>
-          </a:p>
-          <a:p>
-            <a:endParaRPr lang="en-GB" b="1" dirty="0"/>
-          </a:p>
-          <a:p>
-            <a:endParaRPr lang="en-GB" dirty="0"/>
-          </a:p>
-          <a:p>
-            <a:r>
-              <a:rPr lang="en-GB" b="1" dirty="0"/>
+            <a:endParaRPr lang="en-GB"/>
+          </a:p>
+          <a:p>
+            <a:r>
+              <a:rPr lang="en-GB"/>
+              <a:t>Say what follows.</a:t>
+            </a:r>
+          </a:p>
+          <a:p>
+            <a:r>
+              <a:rPr lang="en-GB"/>
+              <a:t>Say: "When every Key Result has been taken through the four steps, your group goes on to 5.3."</a:t>
+            </a:r>
+          </a:p>
+          <a:p>
+            <a:endParaRPr lang="en-GB"/>
+          </a:p>
+          <a:p>
+            <a:endParaRPr lang="en-GB"/>
+          </a:p>
+          <a:p>
+            <a:r>
+              <a:rPr lang="en-GB"/>
               <a:t>Walk the four steps on the slide. Each one is taken for one Key Result at a time.</a:t>
             </a:r>
           </a:p>
           <a:p>
-            <a:pPr marL="171450" indent="-171450">
-              <a:buFontTx/>
-              <a:buChar char="-"/>
-            </a:pPr>
-            <a:r>
-              <a:rPr lang="en-GB" dirty="0"/>
+            <a:r>
+              <a:rPr lang="en-GB"/>
               <a:t>Step 1 · Define the Arena. The group says which customer need the Key Result serves, at three depths (functional, experiential, consequential). Then names what must remain true about that need.</a:t>
             </a:r>
           </a:p>
           <a:p>
-            <a:pPr marL="171450" indent="-171450">
-              <a:buFontTx/>
-              <a:buChar char="-"/>
-            </a:pPr>
-            <a:endParaRPr lang="en-GB" dirty="0"/>
-          </a:p>
-          <a:p>
-            <a:pPr marL="171450" indent="-171450">
-              <a:buFontTx/>
-              <a:buChar char="-"/>
-            </a:pPr>
-            <a:r>
-              <a:rPr lang="en-GB" dirty="0"/>
+            <a:endParaRPr lang="en-GB"/>
+          </a:p>
+          <a:p>
+            <a:r>
+              <a:rPr lang="en-GB"/>
               <a:t>Step 2 · Understand the Boundaries. The group lists the boundaries material enough to slow, restrict or prevent delivery of the Key Result, with the kind of each and whether it must be accepted, can be influenced or was created by the organisation itself. Then it names what must remain true for delivery.</a:t>
             </a:r>
           </a:p>
           <a:p>
-            <a:pPr marL="171450" indent="-171450">
-              <a:buFontTx/>
-              <a:buChar char="-"/>
-            </a:pPr>
-            <a:endParaRPr lang="en-GB" dirty="0"/>
-          </a:p>
-          <a:p>
-            <a:pPr marL="171450" indent="-171450">
-              <a:buFontTx/>
-              <a:buChar char="-"/>
-            </a:pPr>
-            <a:r>
-              <a:rPr lang="en-GB" dirty="0"/>
+            <a:endParaRPr lang="en-GB"/>
+          </a:p>
+          <a:p>
+            <a:r>
+              <a:rPr lang="en-GB"/>
               <a:t>Step 3 · See the Competition. The group lists who or what else can give the customer what the Key Result delivers, including alternatives outside the industry and doing nothing. Then it names what must remain true about its advantage.</a:t>
             </a:r>
           </a:p>
           <a:p>
-            <a:pPr marL="171450" indent="-171450">
-              <a:buFontTx/>
-              <a:buChar char="-"/>
-            </a:pPr>
-            <a:endParaRPr lang="en-GB" dirty="0"/>
-          </a:p>
-          <a:p>
-            <a:pPr marL="171450" indent="-171450">
-              <a:buFontTx/>
-              <a:buChar char="-"/>
-            </a:pPr>
-            <a:r>
-              <a:rPr lang="en-GB" dirty="0"/>
+            <a:endParaRPr lang="en-GB"/>
+          </a:p>
+          <a:p>
+            <a:r>
+              <a:rPr lang="en-GB"/>
               <a:t>Step 4 · Establish the Value Proposition. The group says what about the Key Result will make customers choose the organisation, using the three tests (relevant, distinctive, deliverable). Then it names what must remain true about its value architecture.</a:t>
             </a:r>
           </a:p>
           <a:p>
-            <a:pPr marL="0" indent="0">
-              <a:buFontTx/>
-              <a:buNone/>
-            </a:pPr>
-            <a:endParaRPr lang="en-GB" dirty="0"/>
-          </a:p>
-          <a:p>
-            <a:endParaRPr lang="en-GB" dirty="0"/>
-          </a:p>
-          <a:p>
-            <a:r>
-              <a:rPr lang="en-GB" b="1" dirty="0"/>
+            <a:endParaRPr lang="en-GB"/>
+          </a:p>
+          <a:p>
+            <a:endParaRPr lang="en-GB"/>
+          </a:p>
+          <a:p>
+            <a:r>
+              <a:rPr lang="en-GB"/>
               <a:t>2. Say how the questions read on the page.</a:t>
             </a:r>
           </a:p>
           <a:p>
             <a:r>
-              <a:rPr lang="en-GB" dirty="0"/>
+              <a:rPr lang="en-GB"/>
               <a:t>Say: "On your page every question names your own Key Result, word for word. You answer about that Key Result and no other."</a:t>
             </a:r>
           </a:p>
           <a:p>
-            <a:endParaRPr lang="en-GB" dirty="0"/>
-          </a:p>
-          <a:p>
-            <a:r>
-              <a:rPr lang="en-GB" b="1" dirty="0"/>
+            <a:endParaRPr lang="en-GB"/>
+          </a:p>
+          <a:p>
+            <a:r>
+              <a:rPr lang="en-GB"/>
               <a:t>3. Set the standard for a condition.</a:t>
             </a:r>
           </a:p>
           <a:p>
             <a:r>
-              <a:rPr lang="en-GB" dirty="0"/>
+              <a:rPr lang="en-GB"/>
               <a:t>Say: "The condition your group names must be specific enough that someone else could attempt to verify it.</a:t>
             </a:r>
           </a:p>
           <a:p>
             <a:r>
-              <a:rPr lang="en-GB" dirty="0"/>
+              <a:rPr lang="en-GB"/>
               <a:t>“The market must support us” becomes a condition once it names what must be true, for whom and by when.</a:t>
             </a:r>
           </a:p>
           <a:p>
             <a:r>
-              <a:rPr lang="en-GB" dirty="0"/>
+              <a:rPr lang="en-GB"/>
               <a:t>"</a:t>
             </a:r>
           </a:p>
           <a:p>
             <a:r>
-              <a:rPr lang="en-GB" dirty="0"/>
+              <a:rPr lang="en-GB"/>
               <a:t>How each condition is written: as a statement that is either true or false. The group restates a risk or a concern as the condition that must hold.</a:t>
             </a:r>
           </a:p>
           <a:p>
             <a:r>
-              <a:rPr lang="en-GB" dirty="0"/>
+              <a:rPr lang="en-GB"/>
               <a:t>Where a group cannot name a condition: the Key Result itself may be insufficiently grounded. The group asks itself what that tells it about the Key Result.</a:t>
             </a:r>
           </a:p>
           <a:p>
             <a:r>
-              <a:rPr lang="en-GB" dirty="0"/>
+              <a:rPr lang="en-GB"/>
               <a:t>Ask: "If you cannot name a Must-Be-True, what does that tell you about this Key Result?"</a:t>
             </a:r>
           </a:p>
           <a:p>
-            <a:endParaRPr lang="en-GB" dirty="0"/>
-          </a:p>
-          <a:p>
-            <a:endParaRPr lang="en-GB" dirty="0"/>
-          </a:p>
-          <a:p>
-            <a:r>
-              <a:rPr lang="en-GB" b="1" dirty="0"/>
-              <a:t>Close the section with the commitment question.</a:t>
-            </a:r>
-          </a:p>
-          <a:p>
-            <a:r>
-              <a:rPr lang="en-GB" dirty="0"/>
+            <a:endParaRPr lang="en-GB"/>
+          </a:p>
+          <a:p>
+            <a:endParaRPr lang="en-GB"/>
+          </a:p>
+          <a:p>
+            <a:r>
+              <a:rPr lang="en-GB"/>
+              <a:t>Lead into 5.3 with the question it answers.</a:t>
+            </a:r>
+          </a:p>
+          <a:p>
+            <a:r>
+              <a:rPr lang="en-GB"/>
               <a:t>Ask: "Which one MBT condition, if left unverified, represents the greatest risk to our strategy’s integrity? Who is responsible for that verification?"</a:t>
             </a:r>
           </a:p>
           <a:p>
-            <a:endParaRPr lang="en-GB" dirty="0"/>
-          </a:p>
-          <a:p>
-            <a:r>
-              <a:rPr lang="en-GB" b="1" dirty="0"/>
+            <a:endParaRPr lang="en-GB"/>
+          </a:p>
+          <a:p>
+            <a:r>
+              <a:rPr lang="en-GB"/>
               <a:t>ON THE PORTAL, AFTER THE TEACHING:</a:t>
             </a:r>
           </a:p>
           <a:p>
             <a:r>
-              <a:rPr lang="en-GB" dirty="0"/>
+              <a:rPr lang="en-GB"/>
               <a:t>Participants work in their groups in 5.2 of the participant file. This is Capstone work.</a:t>
             </a:r>
           </a:p>
           <a:p>
             <a:r>
-              <a:rPr lang="en-GB" dirty="0"/>
+              <a:rPr lang="en-GB"/>
               <a:t>1. The group’s confirmed Key Results from Unit 3 are listed in 5.2.</a:t>
             </a:r>
           </a:p>
           <a:p>
             <a:r>
-              <a:rPr lang="en-GB" dirty="0"/>
+              <a:rPr lang="en-GB"/>
               <a:t>2. The group takes one Key Result through the four steps and names the condition at each step.</a:t>
             </a:r>
           </a:p>
           <a:p>
             <a:r>
-              <a:rPr lang="en-GB" dirty="0"/>
+              <a:rPr lang="en-GB"/>
               <a:t>3. The group takes the next Key Result through the same four steps, until every Key Result is complete.</a:t>
             </a:r>
           </a:p>
           <a:p>
             <a:r>
-              <a:rPr lang="en-GB" dirty="0"/>
-              <a:t>4. A record shows the condition named at each step for every Key Result. Each participant confirms the record. Print gives a copy.</a:t>
-            </a:r>
-          </a:p>
-          <a:p>
-            <a:endParaRPr lang="en-GB" dirty="0"/>
-          </a:p>
-          <a:p>
-            <a:r>
-              <a:rPr lang="en-GB" b="1" dirty="0"/>
+              <a:rPr lang="en-GB"/>
+              <a:t>4. A record shows the condition named at each step for every Key Result. The group then goes on to 5.3.</a:t>
+            </a:r>
+          </a:p>
+          <a:p>
+            <a:endParaRPr lang="en-GB"/>
+          </a:p>
+          <a:p>
+            <a:r>
+              <a:rPr lang="en-GB"/>
               <a:t>AFTER THE SESSION:</a:t>
             </a:r>
           </a:p>
           <a:p>
             <a:r>
-              <a:rPr lang="en-GB" dirty="0"/>
+              <a:rPr lang="en-GB"/>
               <a:t>The record reaches you with each participant’s submission, under the heading ABCV–MBT: Stress-Testing the Key Results.</a:t>
             </a:r>
           </a:p>
           <a:p>
             <a:r>
-              <a:rPr lang="en-GB" dirty="0"/>
+              <a:rPr lang="en-GB"/>
               <a:t>The confirmed conditions feed boxes 4A to 4D of the team’s Capstone Blueprint.</a:t>
             </a:r>
           </a:p>
@@ -5402,161 +5377,161 @@
           <a:lstStyle/>
           <a:p>
             <a:r>
-              <a:rPr lang="en-GB" b="1" dirty="0"/>
+              <a:rPr lang="en-GB"/>
               <a:t>UNIT SUMMARY (UNIT 4 SYNTHESIS)</a:t>
             </a:r>
           </a:p>
           <a:p>
-            <a:endParaRPr lang="en-GB" dirty="0"/>
-          </a:p>
-          <a:p>
-            <a:r>
-              <a:rPr lang="en-GB" b="1" dirty="0"/>
+            <a:endParaRPr lang="en-GB"/>
+          </a:p>
+          <a:p>
+            <a:r>
+              <a:rPr lang="en-GB"/>
               <a:t>HOW TO TEACH IT:</a:t>
             </a:r>
           </a:p>
           <a:p>
-            <a:endParaRPr lang="en-GB" dirty="0"/>
-          </a:p>
-          <a:p>
-            <a:r>
-              <a:rPr lang="en-GB" b="1" dirty="0"/>
+            <a:endParaRPr lang="en-GB"/>
+          </a:p>
+          <a:p>
+            <a:r>
+              <a:rPr lang="en-GB"/>
               <a:t>1. Recap the unit, section by section.</a:t>
             </a:r>
           </a:p>
           <a:p>
             <a:r>
-              <a:rPr lang="en-GB" dirty="0"/>
+              <a:rPr lang="en-GB"/>
               <a:t>Say: "This session was about ensuring strategic direction is structurally sound before the first move of execution is made.</a:t>
             </a:r>
           </a:p>
           <a:p>
             <a:r>
-              <a:rPr lang="en-GB" dirty="0"/>
+              <a:rPr lang="en-GB"/>
               <a:t>The ABCV–MBT framework served as our strategic integrity filter."</a:t>
             </a:r>
           </a:p>
           <a:p>
             <a:r>
-              <a:rPr lang="en-GB" dirty="0"/>
+              <a:rPr lang="en-GB"/>
               <a:t>- 1 · Awareness: a well-written OKR can still rest on unnamed conditions. ABCV examines the strategic logic at four checkpoints, and a Must-Be-True condition at each makes the underlying assumption explicit.</a:t>
             </a:r>
           </a:p>
           <a:p>
             <a:r>
-              <a:rPr lang="en-GB" dirty="0"/>
+              <a:rPr lang="en-GB"/>
               <a:t>- 2 · Intelligence: industry knowledge becomes a frame, and three reinforcing traps (Familiarity, Exclusion and Complacency) turn that frame into the boundary of the world leaders examine.</a:t>
             </a:r>
           </a:p>
           <a:p>
             <a:r>
-              <a:rPr lang="en-GB" dirty="0"/>
+              <a:rPr lang="en-GB"/>
               <a:t>- 3 · Extrapolating: every executive role sees through a specialised perspective, and each has a checkpoint it most often overlooks.</a:t>
             </a:r>
           </a:p>
           <a:p>
             <a:r>
-              <a:rPr lang="en-GB" dirty="0"/>
-              <a:t>- 4 · Integration: each group takes the Key Results it confirmed in Unit 3 through four steps and names the condition that must remain true at each step.</a:t>
-            </a:r>
-          </a:p>
-          <a:p>
-            <a:r>
-              <a:rPr lang="en-GB" dirty="0"/>
-              <a:t>- 5 · Application: in Cause of Death each participant tests four failed strategies against the Industry Illusion.</a:t>
-            </a:r>
-          </a:p>
-          <a:p>
-            <a:endParaRPr lang="en-GB" dirty="0"/>
-          </a:p>
-          <a:p>
-            <a:r>
-              <a:rPr lang="en-GB" b="1" dirty="0"/>
+              <a:rPr lang="en-GB"/>
+              <a:t>- 4 · Integration: in Cause of Death each participant tests four failed strategies against the Industry Illusion.</a:t>
+            </a:r>
+          </a:p>
+          <a:p>
+            <a:r>
+              <a:rPr lang="en-GB"/>
+              <a:t>- 5 · Application: each group takes the Key Results it confirmed in Unit 3 through four steps, names the condition that must remain true at each step, assigns each critical condition to an executive and names the checkpoint its team is most likely to overlook.</a:t>
+            </a:r>
+          </a:p>
+          <a:p>
+            <a:endParaRPr lang="en-GB"/>
+          </a:p>
+          <a:p>
+            <a:r>
+              <a:rPr lang="en-GB"/>
               <a:t>2. Ask the closing question on the slide.</a:t>
             </a:r>
           </a:p>
           <a:p>
             <a:r>
-              <a:rPr lang="en-GB" dirty="0"/>
+              <a:rPr lang="en-GB"/>
               <a:t>Ask: "What is the one MBT condition your team is most likely to avoid naming? Why? And what will you do about it before the next strategic review?"</a:t>
             </a:r>
           </a:p>
           <a:p>
             <a:r>
-              <a:rPr lang="en-GB" dirty="0"/>
+              <a:rPr lang="en-GB"/>
               <a:t>Take an answer from each group.</a:t>
             </a:r>
           </a:p>
           <a:p>
-            <a:endParaRPr lang="en-GB" dirty="0"/>
-          </a:p>
-          <a:p>
-            <a:r>
-              <a:rPr lang="en-GB" b="1" dirty="0"/>
+            <a:endParaRPr lang="en-GB"/>
+          </a:p>
+          <a:p>
+            <a:r>
+              <a:rPr lang="en-GB"/>
               <a:t>3. Close the unit.</a:t>
             </a:r>
           </a:p>
           <a:p>
             <a:r>
-              <a:rPr lang="en-GB" dirty="0"/>
+              <a:rPr lang="en-GB"/>
               <a:t>Say: "The ABCV–MBT checkpoints turn your OKRs from polished aspirations into resilient execution signals, grounded in the hard realities of the enterprise system."</a:t>
             </a:r>
           </a:p>
           <a:p>
-            <a:endParaRPr lang="en-GB" dirty="0"/>
-          </a:p>
-          <a:p>
-            <a:r>
-              <a:rPr lang="en-GB" b="1" dirty="0"/>
+            <a:endParaRPr lang="en-GB"/>
+          </a:p>
+          <a:p>
+            <a:r>
+              <a:rPr lang="en-GB"/>
               <a:t>4. Say what happens on the portal.</a:t>
             </a:r>
           </a:p>
           <a:p>
             <a:r>
-              <a:rPr lang="en-GB" dirty="0"/>
+              <a:rPr lang="en-GB"/>
               <a:t>Say: "You now complete the unit on the portal: your reflections, your own Industry Illusion game, your group’s work in Section 5, Cause of Death and your closing commitment.</a:t>
             </a:r>
           </a:p>
           <a:p>
             <a:r>
-              <a:rPr lang="en-GB" dirty="0"/>
+              <a:rPr lang="en-GB"/>
               <a:t>When your page is complete, you submit the unit."</a:t>
             </a:r>
           </a:p>
           <a:p>
-            <a:endParaRPr lang="en-GB" dirty="0"/>
-          </a:p>
-          <a:p>
-            <a:r>
-              <a:rPr lang="en-GB" b="1" dirty="0"/>
+            <a:endParaRPr lang="en-GB"/>
+          </a:p>
+          <a:p>
+            <a:r>
+              <a:rPr lang="en-GB"/>
               <a:t>ON THE PORTAL, AFTER THE TEACHING:</a:t>
             </a:r>
           </a:p>
           <a:p>
             <a:r>
-              <a:rPr lang="en-GB" dirty="0"/>
+              <a:rPr lang="en-GB"/>
               <a:t>Participants complete every part of the participant file and submit the unit to the facilitator from the end of Section 4.</a:t>
             </a:r>
           </a:p>
           <a:p>
-            <a:endParaRPr lang="en-GB" dirty="0"/>
-          </a:p>
-          <a:p>
-            <a:r>
-              <a:rPr lang="en-GB" b="1" dirty="0"/>
+            <a:endParaRPr lang="en-GB"/>
+          </a:p>
+          <a:p>
+            <a:r>
+              <a:rPr lang="en-GB"/>
               <a:t>AFTER THE SESSION:</a:t>
             </a:r>
           </a:p>
           <a:p>
             <a:r>
-              <a:rPr lang="en-GB" dirty="0"/>
+              <a:rPr lang="en-GB"/>
               <a:t>Each submission reaches you in the facilitator dashboard.</a:t>
             </a:r>
           </a:p>
           <a:p>
             <a:r>
-              <a:rPr lang="en-GB" dirty="0"/>
-              <a:t>The confirmed Must-Be-True conditions feed boxes 4A to 4D of the team’s Capstone Blueprint.</a:t>
+              <a:rPr lang="en-GB"/>
+              <a:t>The group’s agreed Section 5 work feeds boxes 4A to 4F of the team’s Capstone Blueprint.</a:t>
             </a:r>
           </a:p>
         </p:txBody>
@@ -5829,6 +5804,235 @@
         <p14:creationId xmlns:p14="http://schemas.microsoft.com/office/powerpoint/2010/main" val="1024086991"/>
       </p:ext>
     </p:extLst>
+  </p:cSld>
+  <p:clrMapOvr>
+    <a:masterClrMapping/>
+  </p:clrMapOvr>
+</p:notes>
+</file>
+
+<file path=ppt/notesSlides/notesSlide30.xml><?xml version="1.0" encoding="utf-8"?>
+<p:notes xmlns:a="http://schemas.openxmlformats.org/drawingml/2006/main" xmlns:p="http://schemas.openxmlformats.org/presentationml/2006/main" xmlns:r="http://schemas.openxmlformats.org/officeDocument/2006/relationships">
+  <p:cSld>
+    <p:spTree>
+      <p:nvGrpSpPr>
+        <p:cNvPr id="1" name=""/>
+        <p:cNvGrpSpPr/>
+        <p:nvPr/>
+      </p:nvGrpSpPr>
+      <p:grpSpPr>
+        <a:xfrm>
+          <a:off x="0" y="0"/>
+          <a:ext cx="0" cy="0"/>
+          <a:chOff x="0" y="0"/>
+          <a:chExt cx="0" cy="0"/>
+        </a:xfrm>
+      </p:grpSpPr>
+      <p:sp>
+        <p:nvSpPr>
+          <p:cNvPr id="2" name="Slide Image Placeholder 1"/>
+          <p:cNvSpPr>
+            <a:spLocks noGrp="1" noRot="1" noChangeAspect="1"/>
+          </p:cNvSpPr>
+          <p:nvPr>
+            <p:ph type="sldImg"/>
+          </p:nvPr>
+        </p:nvSpPr>
+        <p:spPr/>
+      </p:sp>
+      <p:sp>
+        <p:nvSpPr>
+          <p:cNvPr id="3" name="Notes Placeholder 2"/>
+          <p:cNvSpPr>
+            <a:spLocks noGrp="1"/>
+          </p:cNvSpPr>
+          <p:nvPr>
+            <p:ph type="body" idx="1"/>
+          </p:nvPr>
+        </p:nvSpPr>
+        <p:spPr/>
+        <p:txBody>
+          <a:bodyPr/>
+          <a:lstStyle/>
+          <a:p>
+            <a:r>
+              <a:rPr lang="en-GB"/>
+              <a:t>5.3 — VERIFICATION OWNERSHIP AND EXECUTIVE BLIND SPOTS (CAPSTONE WORK)</a:t>
+            </a:r>
+          </a:p>
+          <a:p>
+            <a:endParaRPr lang="en-GB"/>
+          </a:p>
+          <a:p>
+            <a:r>
+              <a:rPr lang="en-GB"/>
+              <a:t>HOW TO TEACH IT:</a:t>
+            </a:r>
+          </a:p>
+          <a:p>
+            <a:endParaRPr lang="en-GB"/>
+          </a:p>
+          <a:p>
+            <a:r>
+              <a:rPr lang="en-GB"/>
+              <a:t>1. Say why ownership matters.</a:t>
+            </a:r>
+          </a:p>
+          <a:p>
+            <a:r>
+              <a:rPr lang="en-GB"/>
+              <a:t>Say: "Each Must-Be-True condition your group named in 5.2 holds only while someone checks it.</a:t>
+            </a:r>
+          </a:p>
+          <a:p>
+            <a:r>
+              <a:rPr lang="en-GB"/>
+              <a:t>In 5.3 your group assigns each check to an executive."</a:t>
+            </a:r>
+          </a:p>
+          <a:p>
+            <a:endParaRPr lang="en-GB"/>
+          </a:p>
+          <a:p>
+            <a:r>
+              <a:rPr lang="en-GB"/>
+              <a:t>2. Teach verification ownership.</a:t>
+            </a:r>
+          </a:p>
+          <a:p>
+            <a:r>
+              <a:rPr lang="en-GB"/>
+              <a:t>Say: "For each critical condition, name the executive accountable for verifying it, the evidence that will confirm it still holds, and the date of the first check."</a:t>
+            </a:r>
+          </a:p>
+          <a:p>
+            <a:r>
+              <a:rPr lang="en-GB"/>
+              <a:t>One executive owns each check, with evidence someone else could inspect and a date.</a:t>
+            </a:r>
+          </a:p>
+          <a:p>
+            <a:endParaRPr lang="en-GB"/>
+          </a:p>
+          <a:p>
+            <a:r>
+              <a:rPr lang="en-GB"/>
+              <a:t>3. Teach the executive blind spot.</a:t>
+            </a:r>
+          </a:p>
+          <a:p>
+            <a:r>
+              <a:rPr lang="en-GB"/>
+              <a:t>Say: "Section 3 showed that each executive role tends to overlook one checkpoint.</a:t>
+            </a:r>
+          </a:p>
+          <a:p>
+            <a:r>
+              <a:rPr lang="en-GB"/>
+              <a:t>Look around your table: which checkpoint is your executive team most likely to overlook? What is the enterprise risk if it does?"</a:t>
+            </a:r>
+          </a:p>
+          <a:p>
+            <a:endParaRPr lang="en-GB"/>
+          </a:p>
+          <a:p>
+            <a:r>
+              <a:rPr lang="en-GB"/>
+              <a:t>4. Ask the question 5.3 answers.</a:t>
+            </a:r>
+          </a:p>
+          <a:p>
+            <a:r>
+              <a:rPr lang="en-GB"/>
+              <a:t>Ask: "Which one MBT condition, if left unverified, represents the greatest risk to our strategy’s integrity? Who is responsible for that verification?"</a:t>
+            </a:r>
+          </a:p>
+          <a:p>
+            <a:endParaRPr lang="en-GB"/>
+          </a:p>
+          <a:p>
+            <a:r>
+              <a:rPr lang="en-GB"/>
+              <a:t>ON THE PORTAL, AFTER THE TEACHING:</a:t>
+            </a:r>
+          </a:p>
+          <a:p>
+            <a:r>
+              <a:rPr lang="en-GB"/>
+              <a:t>Participants work in their groups in 5.3 of the participant file. This is Capstone work, typed by the group’s scribe.</a:t>
+            </a:r>
+          </a:p>
+          <a:p>
+            <a:r>
+              <a:rPr lang="en-GB"/>
+              <a:t>1. The group reads its Must-Be-True conditions from 5.2, listed in 5.3.</a:t>
+            </a:r>
+          </a:p>
+          <a:p>
+            <a:r>
+              <a:rPr lang="en-GB"/>
+              <a:t>2. For each critical condition, the group names the executive accountable, the evidence and the date of the first check.</a:t>
+            </a:r>
+          </a:p>
+          <a:p>
+            <a:r>
+              <a:rPr lang="en-GB"/>
+              <a:t>3. The group selects the checkpoint its executive team is most likely to overlook, and states the enterprise risk.</a:t>
+            </a:r>
+          </a:p>
+          <a:p>
+            <a:r>
+              <a:rPr lang="en-GB"/>
+              <a:t>4. Each participant reads the record and selects Agree. Print gives a copy of the record.</a:t>
+            </a:r>
+          </a:p>
+          <a:p>
+            <a:endParaRPr lang="en-GB"/>
+          </a:p>
+          <a:p>
+            <a:r>
+              <a:rPr lang="en-GB"/>
+              <a:t>AFTER THE SESSION:</a:t>
+            </a:r>
+          </a:p>
+          <a:p>
+            <a:r>
+              <a:rPr lang="en-GB"/>
+              <a:t>The record reaches you with each participant’s submission, under the heading ABCV–MBT: Stress-Testing the Key Results.</a:t>
+            </a:r>
+          </a:p>
+          <a:p>
+            <a:r>
+              <a:rPr lang="en-GB"/>
+              <a:t>The agreed work feeds boxes 4A to 4F of the team’s Capstone Blueprint: the conditions in 4A to 4D, verification ownership in 4E and the executive blind spot in 4F.</a:t>
+            </a:r>
+          </a:p>
+        </p:txBody>
+      </p:sp>
+      <p:sp>
+        <p:nvSpPr>
+          <p:cNvPr id="4" name="Slide Number Placeholder 3"/>
+          <p:cNvSpPr>
+            <a:spLocks noGrp="1"/>
+          </p:cNvSpPr>
+          <p:nvPr>
+            <p:ph type="sldNum" sz="quarter" idx="10"/>
+          </p:nvPr>
+        </p:nvSpPr>
+        <p:spPr/>
+        <p:txBody>
+          <a:bodyPr/>
+          <a:lstStyle/>
+          <a:p>
+            <a:fld id="{F7021451-1387-4CA6-816F-3879F97B5CBC}" type="slidenum">
+              <a:rPr lang="en-US"/>
+              <a:t>25</a:t>
+            </a:fld>
+            <a:endParaRPr lang="en-US"/>
+          </a:p>
+        </p:txBody>
+      </p:sp>
+    </p:spTree>
   </p:cSld>
   <p:clrMapOvr>
     <a:masterClrMapping/>
@@ -17136,6 +17340,568 @@
               <a:t>— In Practice</a:t>
             </a:r>
             <a:endParaRPr lang="en-US" sz="2800" dirty="0"/>
+          </a:p>
+        </p:txBody>
+      </p:sp>
+    </p:spTree>
+  </p:cSld>
+  <p:clrMapOvr>
+    <a:masterClrMapping/>
+  </p:clrMapOvr>
+</p:sld>
+</file>
+
+<file path=ppt/slides/slide30.xml><?xml version="1.0" encoding="utf-8"?>
+<p:sld xmlns:a="http://schemas.openxmlformats.org/drawingml/2006/main" xmlns:p="http://schemas.openxmlformats.org/presentationml/2006/main" xmlns:r="http://schemas.openxmlformats.org/officeDocument/2006/relationships">
+  <p:cSld>
+    <p:bg>
+      <p:bgPr>
+        <a:solidFill>
+          <a:srgbClr val="FFFFFF"/>
+        </a:solidFill>
+        <a:effectLst/>
+      </p:bgPr>
+    </p:bg>
+    <p:spTree>
+      <p:nvGrpSpPr>
+        <p:cNvPr id="1" name=""/>
+        <p:cNvGrpSpPr/>
+        <p:nvPr/>
+      </p:nvGrpSpPr>
+      <p:grpSpPr/>
+      <p:sp>
+        <p:nvSpPr>
+          <p:cNvPr id="2" name="Text 0"/>
+          <p:cNvSpPr txBox="1"/>
+          <p:nvPr/>
+        </p:nvSpPr>
+        <p:spPr>
+          <a:xfrm>
+            <a:off x="548640" y="411480"/>
+            <a:ext cx="11064240" cy="868680"/>
+          </a:xfrm>
+          <a:prstGeom prst="rect">
+            <a:avLst/>
+          </a:prstGeom>
+          <a:noFill/>
+          <a:ln/>
+        </p:spPr>
+        <p:txBody>
+          <a:bodyPr wrap="square" lIns="0" tIns="0" rIns="0" bIns="0" rtlCol="0" anchor="ctr"/>
+          <a:lstStyle/>
+          <a:p>
+            <a:pPr marL="0" indent="0">
+              <a:buNone/>
+            </a:pPr>
+            <a:r>
+              <a:rPr lang="en-US" sz="3600" b="1" dirty="0">
+                <a:solidFill>
+                  <a:srgbClr val="1A5C2C"/>
+                </a:solidFill>
+                <a:latin typeface="Cambria" pitchFamily="34" charset="0"/>
+                <a:ea typeface="Cambria" pitchFamily="34" charset="-122"/>
+                <a:cs typeface="Cambria" pitchFamily="34" charset="-120"/>
+              </a:rPr>
+              <a:t>5.3 · Verification Ownership and Executive Blind Spots</a:t>
+            </a:r>
+            <a:endParaRPr lang="en-US" sz="3600" dirty="0"/>
+          </a:p>
+        </p:txBody>
+      </p:sp>
+      <p:sp>
+        <p:nvSpPr>
+          <p:cNvPr id="3" name="Shape 1"/>
+          <p:cNvSpPr/>
+          <p:nvPr/>
+        </p:nvSpPr>
+        <p:spPr>
+          <a:xfrm>
+            <a:off x="548640" y="1685925"/>
+            <a:ext cx="640080" cy="640080"/>
+          </a:xfrm>
+          <a:prstGeom prst="ellipse">
+            <a:avLst/>
+          </a:prstGeom>
+          <a:solidFill>
+            <a:srgbClr val="1A5C2C"/>
+          </a:solidFill>
+          <a:ln w="12700">
+            <a:solidFill>
+              <a:srgbClr val="1A5C2C"/>
+            </a:solidFill>
+            <a:prstDash val="solid"/>
+          </a:ln>
+        </p:spPr>
+        <p:txBody>
+          <a:bodyPr/>
+          <a:lstStyle/>
+          <a:p>
+            <a:endParaRPr lang="en-ZA"/>
+          </a:p>
+        </p:txBody>
+      </p:sp>
+      <p:pic>
+        <p:nvPicPr>
+          <p:cNvPr id="4" name="Image 0" descr="preencoded.png"/>
+          <p:cNvPicPr>
+            <a:picLocks noChangeAspect="1"/>
+          </p:cNvPicPr>
+          <p:nvPr/>
+        </p:nvPicPr>
+        <p:blipFill>
+          <a:blip r:embed="rId2"/>
+          <a:stretch>
+            <a:fillRect/>
+          </a:stretch>
+        </p:blipFill>
+        <p:spPr>
+          <a:xfrm>
+            <a:off x="708660" y="1845945"/>
+            <a:ext cx="320040" cy="320040"/>
+          </a:xfrm>
+          <a:prstGeom prst="rect">
+            <a:avLst/>
+          </a:prstGeom>
+        </p:spPr>
+      </p:pic>
+      <p:sp>
+        <p:nvSpPr>
+          <p:cNvPr id="5" name="Text 2"/>
+          <p:cNvSpPr txBox="1"/>
+          <p:nvPr/>
+        </p:nvSpPr>
+        <p:spPr>
+          <a:xfrm>
+            <a:off x="1508760" y="1508760"/>
+            <a:ext cx="10131552" cy="994410"/>
+          </a:xfrm>
+          <a:prstGeom prst="rect">
+            <a:avLst/>
+          </a:prstGeom>
+          <a:noFill/>
+          <a:ln/>
+        </p:spPr>
+        <p:txBody>
+          <a:bodyPr wrap="square" lIns="0" tIns="0" rIns="0" bIns="0" rtlCol="0" anchor="ctr"/>
+          <a:lstStyle/>
+          <a:p>
+            <a:pPr marL="0" indent="0">
+              <a:buNone/>
+            </a:pPr>
+            <a:r>
+              <a:rPr lang="en-US" sz="2400" b="1" dirty="0">
+                <a:solidFill>
+                  <a:srgbClr val="1A5C2C"/>
+                </a:solidFill>
+                <a:latin typeface="Cambria" pitchFamily="34" charset="0"/>
+                <a:ea typeface="Cambria" pitchFamily="34" charset="-122"/>
+                <a:cs typeface="Cambria" pitchFamily="34" charset="-120"/>
+              </a:rPr>
+              <a:t>1 · Read your conditions  </a:t>
+            </a:r>
+            <a:r>
+              <a:rPr lang="en-US" sz="2400" dirty="0">
+                <a:solidFill>
+                  <a:srgbClr val="1F2A22"/>
+                </a:solidFill>
+                <a:latin typeface="Calibri" pitchFamily="34" charset="0"/>
+                <a:ea typeface="Calibri" pitchFamily="34" charset="-122"/>
+                <a:cs typeface="Calibri" pitchFamily="34" charset="-120"/>
+              </a:rPr>
+              <a:t>the Must-Be-True conditions your group named in 5.2</a:t>
+            </a:r>
+            <a:endParaRPr lang="en-US" sz="2400" dirty="0"/>
+          </a:p>
+        </p:txBody>
+      </p:sp>
+      <p:sp>
+        <p:nvSpPr>
+          <p:cNvPr id="6" name="Shape 3"/>
+          <p:cNvSpPr/>
+          <p:nvPr/>
+        </p:nvSpPr>
+        <p:spPr>
+          <a:xfrm>
+            <a:off x="548640" y="2680335"/>
+            <a:ext cx="640080" cy="640080"/>
+          </a:xfrm>
+          <a:prstGeom prst="ellipse">
+            <a:avLst/>
+          </a:prstGeom>
+          <a:solidFill>
+            <a:srgbClr val="1A5C2C"/>
+          </a:solidFill>
+          <a:ln w="12700">
+            <a:solidFill>
+              <a:srgbClr val="1A5C2C"/>
+            </a:solidFill>
+            <a:prstDash val="solid"/>
+          </a:ln>
+        </p:spPr>
+        <p:txBody>
+          <a:bodyPr/>
+          <a:lstStyle/>
+          <a:p>
+            <a:endParaRPr lang="en-ZA"/>
+          </a:p>
+        </p:txBody>
+      </p:sp>
+      <p:pic>
+        <p:nvPicPr>
+          <p:cNvPr id="7" name="Image 1" descr="preencoded.png"/>
+          <p:cNvPicPr>
+            <a:picLocks noChangeAspect="1"/>
+          </p:cNvPicPr>
+          <p:nvPr/>
+        </p:nvPicPr>
+        <p:blipFill>
+          <a:blip r:embed="rId3"/>
+          <a:stretch>
+            <a:fillRect/>
+          </a:stretch>
+        </p:blipFill>
+        <p:spPr>
+          <a:xfrm>
+            <a:off x="708660" y="2840355"/>
+            <a:ext cx="320040" cy="320040"/>
+          </a:xfrm>
+          <a:prstGeom prst="rect">
+            <a:avLst/>
+          </a:prstGeom>
+        </p:spPr>
+      </p:pic>
+      <p:sp>
+        <p:nvSpPr>
+          <p:cNvPr id="8" name="Text 4"/>
+          <p:cNvSpPr txBox="1"/>
+          <p:nvPr/>
+        </p:nvSpPr>
+        <p:spPr>
+          <a:xfrm>
+            <a:off x="1508760" y="2503170"/>
+            <a:ext cx="10131552" cy="994410"/>
+          </a:xfrm>
+          <a:prstGeom prst="rect">
+            <a:avLst/>
+          </a:prstGeom>
+          <a:noFill/>
+          <a:ln/>
+        </p:spPr>
+        <p:txBody>
+          <a:bodyPr wrap="square" lIns="0" tIns="0" rIns="0" bIns="0" rtlCol="0" anchor="ctr"/>
+          <a:lstStyle/>
+          <a:p>
+            <a:pPr marL="0" indent="0">
+              <a:buNone/>
+            </a:pPr>
+            <a:r>
+              <a:rPr lang="en-US" sz="2400" b="1" dirty="0">
+                <a:solidFill>
+                  <a:srgbClr val="1A5C2C"/>
+                </a:solidFill>
+                <a:latin typeface="Cambria" pitchFamily="34" charset="0"/>
+                <a:ea typeface="Cambria" pitchFamily="34" charset="-122"/>
+                <a:cs typeface="Cambria" pitchFamily="34" charset="-120"/>
+              </a:rPr>
+              <a:t>2 · Verification ownership  </a:t>
+            </a:r>
+            <a:r>
+              <a:rPr lang="en-US" sz="2400" dirty="0">
+                <a:solidFill>
+                  <a:srgbClr val="1F2A22"/>
+                </a:solidFill>
+                <a:latin typeface="Calibri" pitchFamily="34" charset="0"/>
+                <a:ea typeface="Calibri" pitchFamily="34" charset="-122"/>
+                <a:cs typeface="Calibri" pitchFamily="34" charset="-120"/>
+              </a:rPr>
+              <a:t>the executive, the evidence and the date of the first check</a:t>
+            </a:r>
+            <a:endParaRPr lang="en-US" sz="2400" dirty="0"/>
+          </a:p>
+        </p:txBody>
+      </p:sp>
+      <p:sp>
+        <p:nvSpPr>
+          <p:cNvPr id="9" name="Shape 5"/>
+          <p:cNvSpPr/>
+          <p:nvPr/>
+        </p:nvSpPr>
+        <p:spPr>
+          <a:xfrm>
+            <a:off x="548640" y="3674745"/>
+            <a:ext cx="640080" cy="640080"/>
+          </a:xfrm>
+          <a:prstGeom prst="ellipse">
+            <a:avLst/>
+          </a:prstGeom>
+          <a:solidFill>
+            <a:srgbClr val="1A5C2C"/>
+          </a:solidFill>
+          <a:ln w="12700">
+            <a:solidFill>
+              <a:srgbClr val="1A5C2C"/>
+            </a:solidFill>
+            <a:prstDash val="solid"/>
+          </a:ln>
+        </p:spPr>
+        <p:txBody>
+          <a:bodyPr/>
+          <a:lstStyle/>
+          <a:p>
+            <a:endParaRPr lang="en-ZA"/>
+          </a:p>
+        </p:txBody>
+      </p:sp>
+      <p:pic>
+        <p:nvPicPr>
+          <p:cNvPr id="10" name="Image 2" descr="preencoded.png"/>
+          <p:cNvPicPr>
+            <a:picLocks noChangeAspect="1"/>
+          </p:cNvPicPr>
+          <p:nvPr/>
+        </p:nvPicPr>
+        <p:blipFill>
+          <a:blip r:embed="rId4"/>
+          <a:stretch>
+            <a:fillRect/>
+          </a:stretch>
+        </p:blipFill>
+        <p:spPr>
+          <a:xfrm>
+            <a:off x="708660" y="3834765"/>
+            <a:ext cx="320040" cy="320040"/>
+          </a:xfrm>
+          <a:prstGeom prst="rect">
+            <a:avLst/>
+          </a:prstGeom>
+        </p:spPr>
+      </p:pic>
+      <p:sp>
+        <p:nvSpPr>
+          <p:cNvPr id="11" name="Text 6"/>
+          <p:cNvSpPr txBox="1"/>
+          <p:nvPr/>
+        </p:nvSpPr>
+        <p:spPr>
+          <a:xfrm>
+            <a:off x="1508760" y="3497580"/>
+            <a:ext cx="10131552" cy="994410"/>
+          </a:xfrm>
+          <a:prstGeom prst="rect">
+            <a:avLst/>
+          </a:prstGeom>
+          <a:noFill/>
+          <a:ln/>
+        </p:spPr>
+        <p:txBody>
+          <a:bodyPr wrap="square" lIns="0" tIns="0" rIns="0" bIns="0" rtlCol="0" anchor="ctr"/>
+          <a:lstStyle/>
+          <a:p>
+            <a:pPr marL="0" indent="0">
+              <a:buNone/>
+            </a:pPr>
+            <a:r>
+              <a:rPr lang="en-US" sz="2400" b="1" dirty="0">
+                <a:solidFill>
+                  <a:srgbClr val="1A5C2C"/>
+                </a:solidFill>
+                <a:latin typeface="Cambria" pitchFamily="34" charset="0"/>
+                <a:ea typeface="Cambria" pitchFamily="34" charset="-122"/>
+                <a:cs typeface="Cambria" pitchFamily="34" charset="-120"/>
+              </a:rPr>
+              <a:t>3 · Executive blind spot  </a:t>
+            </a:r>
+            <a:r>
+              <a:rPr lang="en-US" sz="2400" dirty="0">
+                <a:solidFill>
+                  <a:srgbClr val="1F2A22"/>
+                </a:solidFill>
+                <a:latin typeface="Calibri" pitchFamily="34" charset="0"/>
+                <a:ea typeface="Calibri" pitchFamily="34" charset="-122"/>
+                <a:cs typeface="Calibri" pitchFamily="34" charset="-120"/>
+              </a:rPr>
+              <a:t>the checkpoint your team is most likely to overlook, and the risk</a:t>
+            </a:r>
+            <a:endParaRPr lang="en-US" sz="2400" dirty="0"/>
+          </a:p>
+        </p:txBody>
+      </p:sp>
+      <p:sp>
+        <p:nvSpPr>
+          <p:cNvPr id="12" name="Shape 7"/>
+          <p:cNvSpPr/>
+          <p:nvPr/>
+        </p:nvSpPr>
+        <p:spPr>
+          <a:xfrm>
+            <a:off x="548640" y="4669155"/>
+            <a:ext cx="640080" cy="640080"/>
+          </a:xfrm>
+          <a:prstGeom prst="ellipse">
+            <a:avLst/>
+          </a:prstGeom>
+          <a:solidFill>
+            <a:srgbClr val="1A5C2C"/>
+          </a:solidFill>
+          <a:ln w="12700">
+            <a:solidFill>
+              <a:srgbClr val="1A5C2C"/>
+            </a:solidFill>
+            <a:prstDash val="solid"/>
+          </a:ln>
+        </p:spPr>
+        <p:txBody>
+          <a:bodyPr/>
+          <a:lstStyle/>
+          <a:p>
+            <a:endParaRPr lang="en-ZA"/>
+          </a:p>
+        </p:txBody>
+      </p:sp>
+      <p:pic>
+        <p:nvPicPr>
+          <p:cNvPr id="13" name="Image 3" descr="preencoded.png"/>
+          <p:cNvPicPr>
+            <a:picLocks noChangeAspect="1"/>
+          </p:cNvPicPr>
+          <p:nvPr/>
+        </p:nvPicPr>
+        <p:blipFill>
+          <a:blip r:embed="rId5"/>
+          <a:stretch>
+            <a:fillRect/>
+          </a:stretch>
+        </p:blipFill>
+        <p:spPr>
+          <a:xfrm>
+            <a:off x="708660" y="4829175"/>
+            <a:ext cx="320040" cy="320040"/>
+          </a:xfrm>
+          <a:prstGeom prst="rect">
+            <a:avLst/>
+          </a:prstGeom>
+        </p:spPr>
+      </p:pic>
+      <p:sp>
+        <p:nvSpPr>
+          <p:cNvPr id="14" name="Text 8"/>
+          <p:cNvSpPr txBox="1"/>
+          <p:nvPr/>
+        </p:nvSpPr>
+        <p:spPr>
+          <a:xfrm>
+            <a:off x="1508760" y="4491990"/>
+            <a:ext cx="10131552" cy="994410"/>
+          </a:xfrm>
+          <a:prstGeom prst="rect">
+            <a:avLst/>
+          </a:prstGeom>
+          <a:noFill/>
+          <a:ln/>
+        </p:spPr>
+        <p:txBody>
+          <a:bodyPr wrap="square" lIns="0" tIns="0" rIns="0" bIns="0" rtlCol="0" anchor="ctr"/>
+          <a:lstStyle/>
+          <a:p>
+            <a:pPr marL="0" indent="0">
+              <a:buNone/>
+            </a:pPr>
+            <a:r>
+              <a:rPr lang="en-US" sz="2400" b="1" dirty="0">
+                <a:solidFill>
+                  <a:srgbClr val="1A5C2C"/>
+                </a:solidFill>
+                <a:latin typeface="Cambria" pitchFamily="34" charset="0"/>
+                <a:ea typeface="Cambria" pitchFamily="34" charset="-122"/>
+                <a:cs typeface="Cambria" pitchFamily="34" charset="-120"/>
+              </a:rPr>
+              <a:t>4 · Agree  </a:t>
+            </a:r>
+            <a:r>
+              <a:rPr lang="en-US" sz="2400" dirty="0">
+                <a:solidFill>
+                  <a:srgbClr val="1F2A22"/>
+                </a:solidFill>
+                <a:latin typeface="Calibri" pitchFamily="34" charset="0"/>
+                <a:ea typeface="Calibri" pitchFamily="34" charset="-122"/>
+                <a:cs typeface="Calibri" pitchFamily="34" charset="-120"/>
+              </a:rPr>
+              <a:t>every member agrees; the work feeds boxes 4A to 4F</a:t>
+            </a:r>
+            <a:endParaRPr lang="en-US" sz="2400" dirty="0"/>
+          </a:p>
+        </p:txBody>
+      </p:sp>
+      <p:sp>
+        <p:nvSpPr>
+          <p:cNvPr id="15" name="Shape 9"/>
+          <p:cNvSpPr/>
+          <p:nvPr/>
+        </p:nvSpPr>
+        <p:spPr>
+          <a:xfrm>
+            <a:off x="548640" y="5623560"/>
+            <a:ext cx="11091672" cy="777240"/>
+          </a:xfrm>
+          <a:prstGeom prst="roundRect">
+            <a:avLst>
+              <a:gd name="adj" fmla="val 11765"/>
+            </a:avLst>
+          </a:prstGeom>
+          <a:solidFill>
+            <a:srgbClr val="0F3B1C"/>
+          </a:solidFill>
+          <a:ln w="12700">
+            <a:solidFill>
+              <a:srgbClr val="0F3B1C"/>
+            </a:solidFill>
+            <a:prstDash val="solid"/>
+          </a:ln>
+        </p:spPr>
+        <p:txBody>
+          <a:bodyPr/>
+          <a:lstStyle/>
+          <a:p>
+            <a:endParaRPr lang="en-ZA"/>
+          </a:p>
+        </p:txBody>
+      </p:sp>
+      <p:sp>
+        <p:nvSpPr>
+          <p:cNvPr id="16" name="Text 10"/>
+          <p:cNvSpPr txBox="1"/>
+          <p:nvPr/>
+        </p:nvSpPr>
+        <p:spPr>
+          <a:xfrm>
+            <a:off x="822960" y="5623560"/>
+            <a:ext cx="10607040" cy="777240"/>
+          </a:xfrm>
+          <a:prstGeom prst="rect">
+            <a:avLst/>
+          </a:prstGeom>
+          <a:noFill/>
+          <a:ln/>
+        </p:spPr>
+        <p:txBody>
+          <a:bodyPr wrap="square" lIns="0" tIns="0" rIns="0" bIns="0" rtlCol="0" anchor="ctr"/>
+          <a:lstStyle/>
+          <a:p>
+            <a:pPr marL="0" indent="0">
+              <a:buNone/>
+            </a:pPr>
+            <a:r>
+              <a:rPr lang="en-US" sz="2400" i="1" dirty="0">
+                <a:solidFill>
+                  <a:srgbClr val="FFFFFF"/>
+                </a:solidFill>
+                <a:latin typeface="Calibri" pitchFamily="34" charset="0"/>
+                <a:ea typeface="Calibri" pitchFamily="34" charset="-122"/>
+                <a:cs typeface="Calibri" pitchFamily="34" charset="-120"/>
+              </a:rPr>
+              <a:t>Every condition has an executive who checks it.</a:t>
+            </a:r>
+            <a:endParaRPr lang="en-US" sz="2400" dirty="0"/>
           </a:p>
         </p:txBody>
       </p:sp>

</xml_diff>